<commit_message>
docs: adiciona links clicaveis na apresentacao (rodape e slide de encerramento)
</commit_message>
<xml_diff>
--- a/docs/Apresentacao_Tech_Challenge_2_10MLE_FIAP.pptx
+++ b/docs/Apresentacao_Tech_Challenge_2_10MLE_FIAP.pptx
@@ -1786,7 +1786,77 @@
                 <a:ea typeface="Calibri" pitchFamily="34" charset="-122"/>
                 <a:cs typeface="Calibri" pitchFamily="34" charset="-120"/>
               </a:rPr>
-              <a:t>FIAP – MLE10 – Machine Learning Engineering    |    github.com/tiagotff/FIAP_MLE10_TC2    |    linkedin.com/in/tiagofaustino91</a:t>
+              <a:t>FIAP – MLE10 – Machine Learning Engineering</a:t>
+            </a:r>
+            <a:pPr algn="ctr" indent="0" marL="0">
+              <a:buNone/>
+            </a:pPr>
+            <a:r>
+              <a:rPr lang="en-US" sz="900" dirty="0">
+                <a:solidFill>
+                  <a:srgbClr val="9DB2A6"/>
+                </a:solidFill>
+                <a:latin typeface="Calibri" pitchFamily="34" charset="0"/>
+                <a:ea typeface="Calibri" pitchFamily="34" charset="-122"/>
+                <a:cs typeface="Calibri" pitchFamily="34" charset="-120"/>
+              </a:rPr>
+              <a:t>    |    </a:t>
+            </a:r>
+            <a:pPr algn="ctr" indent="0" marL="0">
+              <a:buNone/>
+            </a:pPr>
+            <a:r>
+              <a:rPr lang="en-US" sz="900" u="sng" dirty="0">
+                <a:solidFill>
+                  <a:srgbClr val="9DB2A6"/>
+                </a:solidFill>
+                <a:latin typeface="Calibri" pitchFamily="34" charset="0"/>
+                <a:ea typeface="Calibri" pitchFamily="34" charset="-122"/>
+                <a:cs typeface="Calibri" pitchFamily="34" charset="-120"/>
+                <a:hlinkClick r:id="rId3" invalidUrl="" action="" tgtFrame="" tooltip="" history="1" highlightClick="0" endSnd="0">
+                  <a:extLst>
+                    <a:ext uri="{A12FA001-AC4F-418D-AE19-62706E023703}">
+                      <ahyp:hlinkClr xmlns:ahyp="http://schemas.microsoft.com/office/drawing/2018/hyperlinkcolor" val="tx"/>
+                    </a:ext>
+                  </a:extLst>
+                </a:hlinkClick>
+              </a:rPr>
+              <a:t>github.com/tiagotff/FIAP_MLE10_TC2</a:t>
+            </a:r>
+            <a:pPr algn="ctr" indent="0" marL="0">
+              <a:buNone/>
+            </a:pPr>
+            <a:r>
+              <a:rPr lang="en-US" sz="900" dirty="0">
+                <a:solidFill>
+                  <a:srgbClr val="9DB2A6"/>
+                </a:solidFill>
+                <a:latin typeface="Calibri" pitchFamily="34" charset="0"/>
+                <a:ea typeface="Calibri" pitchFamily="34" charset="-122"/>
+                <a:cs typeface="Calibri" pitchFamily="34" charset="-120"/>
+              </a:rPr>
+              <a:t>    |    </a:t>
+            </a:r>
+            <a:pPr algn="ctr" indent="0" marL="0">
+              <a:buNone/>
+            </a:pPr>
+            <a:r>
+              <a:rPr lang="en-US" sz="900" u="sng" dirty="0">
+                <a:solidFill>
+                  <a:srgbClr val="9DB2A6"/>
+                </a:solidFill>
+                <a:latin typeface="Calibri" pitchFamily="34" charset="0"/>
+                <a:ea typeface="Calibri" pitchFamily="34" charset="-122"/>
+                <a:cs typeface="Calibri" pitchFamily="34" charset="-120"/>
+                <a:hlinkClick r:id="rId4" invalidUrl="" action="" tgtFrame="" tooltip="" history="1" highlightClick="0" endSnd="0">
+                  <a:extLst>
+                    <a:ext uri="{A12FA001-AC4F-418D-AE19-62706E023703}">
+                      <ahyp:hlinkClr xmlns:ahyp="http://schemas.microsoft.com/office/drawing/2018/hyperlinkcolor" val="tx"/>
+                    </a:ext>
+                  </a:extLst>
+                </a:hlinkClick>
+              </a:rPr>
+              <a:t>linkedin.com/in/tiagofaustino91</a:t>
             </a:r>
             <a:endParaRPr lang="en-US" sz="900" dirty="0"/>
           </a:p>
@@ -2423,7 +2493,77 @@
                 <a:ea typeface="Calibri" pitchFamily="34" charset="-122"/>
                 <a:cs typeface="Calibri" pitchFamily="34" charset="-120"/>
               </a:rPr>
-              <a:t>FIAP – MLE10 – Machine Learning Engineering    |    github.com/tiagotff/FIAP_MLE10_TC2    |    linkedin.com/in/tiagofaustino91</a:t>
+              <a:t>FIAP – MLE10 – Machine Learning Engineering</a:t>
+            </a:r>
+            <a:pPr algn="ctr" indent="0" marL="0">
+              <a:buNone/>
+            </a:pPr>
+            <a:r>
+              <a:rPr lang="en-US" sz="900" dirty="0">
+                <a:solidFill>
+                  <a:srgbClr val="9AA3B5"/>
+                </a:solidFill>
+                <a:latin typeface="Calibri" pitchFamily="34" charset="0"/>
+                <a:ea typeface="Calibri" pitchFamily="34" charset="-122"/>
+                <a:cs typeface="Calibri" pitchFamily="34" charset="-120"/>
+              </a:rPr>
+              <a:t>    |    </a:t>
+            </a:r>
+            <a:pPr algn="ctr" indent="0" marL="0">
+              <a:buNone/>
+            </a:pPr>
+            <a:r>
+              <a:rPr lang="en-US" sz="900" u="sng" dirty="0">
+                <a:solidFill>
+                  <a:srgbClr val="9AA3B5"/>
+                </a:solidFill>
+                <a:latin typeface="Calibri" pitchFamily="34" charset="0"/>
+                <a:ea typeface="Calibri" pitchFamily="34" charset="-122"/>
+                <a:cs typeface="Calibri" pitchFamily="34" charset="-120"/>
+                <a:hlinkClick r:id="rId1" invalidUrl="" action="" tgtFrame="" tooltip="" history="1" highlightClick="0" endSnd="0">
+                  <a:extLst>
+                    <a:ext uri="{A12FA001-AC4F-418D-AE19-62706E023703}">
+                      <ahyp:hlinkClr xmlns:ahyp="http://schemas.microsoft.com/office/drawing/2018/hyperlinkcolor" val="tx"/>
+                    </a:ext>
+                  </a:extLst>
+                </a:hlinkClick>
+              </a:rPr>
+              <a:t>github.com/tiagotff/FIAP_MLE10_TC2</a:t>
+            </a:r>
+            <a:pPr algn="ctr" indent="0" marL="0">
+              <a:buNone/>
+            </a:pPr>
+            <a:r>
+              <a:rPr lang="en-US" sz="900" dirty="0">
+                <a:solidFill>
+                  <a:srgbClr val="9AA3B5"/>
+                </a:solidFill>
+                <a:latin typeface="Calibri" pitchFamily="34" charset="0"/>
+                <a:ea typeface="Calibri" pitchFamily="34" charset="-122"/>
+                <a:cs typeface="Calibri" pitchFamily="34" charset="-120"/>
+              </a:rPr>
+              <a:t>    |    </a:t>
+            </a:r>
+            <a:pPr algn="ctr" indent="0" marL="0">
+              <a:buNone/>
+            </a:pPr>
+            <a:r>
+              <a:rPr lang="en-US" sz="900" u="sng" dirty="0">
+                <a:solidFill>
+                  <a:srgbClr val="9AA3B5"/>
+                </a:solidFill>
+                <a:latin typeface="Calibri" pitchFamily="34" charset="0"/>
+                <a:ea typeface="Calibri" pitchFamily="34" charset="-122"/>
+                <a:cs typeface="Calibri" pitchFamily="34" charset="-120"/>
+                <a:hlinkClick r:id="rId2" invalidUrl="" action="" tgtFrame="" tooltip="" history="1" highlightClick="0" endSnd="0">
+                  <a:extLst>
+                    <a:ext uri="{A12FA001-AC4F-418D-AE19-62706E023703}">
+                      <ahyp:hlinkClr xmlns:ahyp="http://schemas.microsoft.com/office/drawing/2018/hyperlinkcolor" val="tx"/>
+                    </a:ext>
+                  </a:extLst>
+                </a:hlinkClick>
+              </a:rPr>
+              <a:t>linkedin.com/in/tiagofaustino91</a:t>
             </a:r>
             <a:endParaRPr lang="en-US" sz="900" dirty="0"/>
           </a:p>
@@ -2915,7 +3055,77 @@
                 <a:ea typeface="Calibri" pitchFamily="34" charset="-122"/>
                 <a:cs typeface="Calibri" pitchFamily="34" charset="-120"/>
               </a:rPr>
-              <a:t>FIAP – MLE10 – Machine Learning Engineering    |    github.com/tiagotff/FIAP_MLE10_TC2    |    linkedin.com/in/tiagofaustino91</a:t>
+              <a:t>FIAP – MLE10 – Machine Learning Engineering</a:t>
+            </a:r>
+            <a:pPr algn="ctr" indent="0" marL="0">
+              <a:buNone/>
+            </a:pPr>
+            <a:r>
+              <a:rPr lang="en-US" sz="900" dirty="0">
+                <a:solidFill>
+                  <a:srgbClr val="9AA3B5"/>
+                </a:solidFill>
+                <a:latin typeface="Calibri" pitchFamily="34" charset="0"/>
+                <a:ea typeface="Calibri" pitchFamily="34" charset="-122"/>
+                <a:cs typeface="Calibri" pitchFamily="34" charset="-120"/>
+              </a:rPr>
+              <a:t>    |    </a:t>
+            </a:r>
+            <a:pPr algn="ctr" indent="0" marL="0">
+              <a:buNone/>
+            </a:pPr>
+            <a:r>
+              <a:rPr lang="en-US" sz="900" u="sng" dirty="0">
+                <a:solidFill>
+                  <a:srgbClr val="9AA3B5"/>
+                </a:solidFill>
+                <a:latin typeface="Calibri" pitchFamily="34" charset="0"/>
+                <a:ea typeface="Calibri" pitchFamily="34" charset="-122"/>
+                <a:cs typeface="Calibri" pitchFamily="34" charset="-120"/>
+                <a:hlinkClick r:id="rId1" invalidUrl="" action="" tgtFrame="" tooltip="" history="1" highlightClick="0" endSnd="0">
+                  <a:extLst>
+                    <a:ext uri="{A12FA001-AC4F-418D-AE19-62706E023703}">
+                      <ahyp:hlinkClr xmlns:ahyp="http://schemas.microsoft.com/office/drawing/2018/hyperlinkcolor" val="tx"/>
+                    </a:ext>
+                  </a:extLst>
+                </a:hlinkClick>
+              </a:rPr>
+              <a:t>github.com/tiagotff/FIAP_MLE10_TC2</a:t>
+            </a:r>
+            <a:pPr algn="ctr" indent="0" marL="0">
+              <a:buNone/>
+            </a:pPr>
+            <a:r>
+              <a:rPr lang="en-US" sz="900" dirty="0">
+                <a:solidFill>
+                  <a:srgbClr val="9AA3B5"/>
+                </a:solidFill>
+                <a:latin typeface="Calibri" pitchFamily="34" charset="0"/>
+                <a:ea typeface="Calibri" pitchFamily="34" charset="-122"/>
+                <a:cs typeface="Calibri" pitchFamily="34" charset="-120"/>
+              </a:rPr>
+              <a:t>    |    </a:t>
+            </a:r>
+            <a:pPr algn="ctr" indent="0" marL="0">
+              <a:buNone/>
+            </a:pPr>
+            <a:r>
+              <a:rPr lang="en-US" sz="900" u="sng" dirty="0">
+                <a:solidFill>
+                  <a:srgbClr val="9AA3B5"/>
+                </a:solidFill>
+                <a:latin typeface="Calibri" pitchFamily="34" charset="0"/>
+                <a:ea typeface="Calibri" pitchFamily="34" charset="-122"/>
+                <a:cs typeface="Calibri" pitchFamily="34" charset="-120"/>
+                <a:hlinkClick r:id="rId2" invalidUrl="" action="" tgtFrame="" tooltip="" history="1" highlightClick="0" endSnd="0">
+                  <a:extLst>
+                    <a:ext uri="{A12FA001-AC4F-418D-AE19-62706E023703}">
+                      <ahyp:hlinkClr xmlns:ahyp="http://schemas.microsoft.com/office/drawing/2018/hyperlinkcolor" val="tx"/>
+                    </a:ext>
+                  </a:extLst>
+                </a:hlinkClick>
+              </a:rPr>
+              <a:t>linkedin.com/in/tiagofaustino91</a:t>
             </a:r>
             <a:endParaRPr lang="en-US" sz="900" dirty="0"/>
           </a:p>
@@ -3783,7 +3993,77 @@
                 <a:ea typeface="Calibri" pitchFamily="34" charset="-122"/>
                 <a:cs typeface="Calibri" pitchFamily="34" charset="-120"/>
               </a:rPr>
-              <a:t>FIAP – MLE10 – Machine Learning Engineering    |    github.com/tiagotff/FIAP_MLE10_TC2    |    linkedin.com/in/tiagofaustino91</a:t>
+              <a:t>FIAP – MLE10 – Machine Learning Engineering</a:t>
+            </a:r>
+            <a:pPr algn="ctr" indent="0" marL="0">
+              <a:buNone/>
+            </a:pPr>
+            <a:r>
+              <a:rPr lang="en-US" sz="900" dirty="0">
+                <a:solidFill>
+                  <a:srgbClr val="9AA3B5"/>
+                </a:solidFill>
+                <a:latin typeface="Calibri" pitchFamily="34" charset="0"/>
+                <a:ea typeface="Calibri" pitchFamily="34" charset="-122"/>
+                <a:cs typeface="Calibri" pitchFamily="34" charset="-120"/>
+              </a:rPr>
+              <a:t>    |    </a:t>
+            </a:r>
+            <a:pPr algn="ctr" indent="0" marL="0">
+              <a:buNone/>
+            </a:pPr>
+            <a:r>
+              <a:rPr lang="en-US" sz="900" u="sng" dirty="0">
+                <a:solidFill>
+                  <a:srgbClr val="9AA3B5"/>
+                </a:solidFill>
+                <a:latin typeface="Calibri" pitchFamily="34" charset="0"/>
+                <a:ea typeface="Calibri" pitchFamily="34" charset="-122"/>
+                <a:cs typeface="Calibri" pitchFamily="34" charset="-120"/>
+                <a:hlinkClick r:id="rId1" invalidUrl="" action="" tgtFrame="" tooltip="" history="1" highlightClick="0" endSnd="0">
+                  <a:extLst>
+                    <a:ext uri="{A12FA001-AC4F-418D-AE19-62706E023703}">
+                      <ahyp:hlinkClr xmlns:ahyp="http://schemas.microsoft.com/office/drawing/2018/hyperlinkcolor" val="tx"/>
+                    </a:ext>
+                  </a:extLst>
+                </a:hlinkClick>
+              </a:rPr>
+              <a:t>github.com/tiagotff/FIAP_MLE10_TC2</a:t>
+            </a:r>
+            <a:pPr algn="ctr" indent="0" marL="0">
+              <a:buNone/>
+            </a:pPr>
+            <a:r>
+              <a:rPr lang="en-US" sz="900" dirty="0">
+                <a:solidFill>
+                  <a:srgbClr val="9AA3B5"/>
+                </a:solidFill>
+                <a:latin typeface="Calibri" pitchFamily="34" charset="0"/>
+                <a:ea typeface="Calibri" pitchFamily="34" charset="-122"/>
+                <a:cs typeface="Calibri" pitchFamily="34" charset="-120"/>
+              </a:rPr>
+              <a:t>    |    </a:t>
+            </a:r>
+            <a:pPr algn="ctr" indent="0" marL="0">
+              <a:buNone/>
+            </a:pPr>
+            <a:r>
+              <a:rPr lang="en-US" sz="900" u="sng" dirty="0">
+                <a:solidFill>
+                  <a:srgbClr val="9AA3B5"/>
+                </a:solidFill>
+                <a:latin typeface="Calibri" pitchFamily="34" charset="0"/>
+                <a:ea typeface="Calibri" pitchFamily="34" charset="-122"/>
+                <a:cs typeface="Calibri" pitchFamily="34" charset="-120"/>
+                <a:hlinkClick r:id="rId2" invalidUrl="" action="" tgtFrame="" tooltip="" history="1" highlightClick="0" endSnd="0">
+                  <a:extLst>
+                    <a:ext uri="{A12FA001-AC4F-418D-AE19-62706E023703}">
+                      <ahyp:hlinkClr xmlns:ahyp="http://schemas.microsoft.com/office/drawing/2018/hyperlinkcolor" val="tx"/>
+                    </a:ext>
+                  </a:extLst>
+                </a:hlinkClick>
+              </a:rPr>
+              <a:t>linkedin.com/in/tiagofaustino91</a:t>
             </a:r>
             <a:endParaRPr lang="en-US" sz="900" dirty="0"/>
           </a:p>
@@ -5060,7 +5340,77 @@
                 <a:ea typeface="Calibri" pitchFamily="34" charset="-122"/>
                 <a:cs typeface="Calibri" pitchFamily="34" charset="-120"/>
               </a:rPr>
-              <a:t>FIAP – MLE10 – Machine Learning Engineering    |    github.com/tiagotff/FIAP_MLE10_TC2    |    linkedin.com/in/tiagofaustino91</a:t>
+              <a:t>FIAP – MLE10 – Machine Learning Engineering</a:t>
+            </a:r>
+            <a:pPr algn="ctr" indent="0" marL="0">
+              <a:buNone/>
+            </a:pPr>
+            <a:r>
+              <a:rPr lang="en-US" sz="900" dirty="0">
+                <a:solidFill>
+                  <a:srgbClr val="9AA3B5"/>
+                </a:solidFill>
+                <a:latin typeface="Calibri" pitchFamily="34" charset="0"/>
+                <a:ea typeface="Calibri" pitchFamily="34" charset="-122"/>
+                <a:cs typeface="Calibri" pitchFamily="34" charset="-120"/>
+              </a:rPr>
+              <a:t>    |    </a:t>
+            </a:r>
+            <a:pPr algn="ctr" indent="0" marL="0">
+              <a:buNone/>
+            </a:pPr>
+            <a:r>
+              <a:rPr lang="en-US" sz="900" u="sng" dirty="0">
+                <a:solidFill>
+                  <a:srgbClr val="9AA3B5"/>
+                </a:solidFill>
+                <a:latin typeface="Calibri" pitchFamily="34" charset="0"/>
+                <a:ea typeface="Calibri" pitchFamily="34" charset="-122"/>
+                <a:cs typeface="Calibri" pitchFamily="34" charset="-120"/>
+                <a:hlinkClick r:id="rId1" invalidUrl="" action="" tgtFrame="" tooltip="" history="1" highlightClick="0" endSnd="0">
+                  <a:extLst>
+                    <a:ext uri="{A12FA001-AC4F-418D-AE19-62706E023703}">
+                      <ahyp:hlinkClr xmlns:ahyp="http://schemas.microsoft.com/office/drawing/2018/hyperlinkcolor" val="tx"/>
+                    </a:ext>
+                  </a:extLst>
+                </a:hlinkClick>
+              </a:rPr>
+              <a:t>github.com/tiagotff/FIAP_MLE10_TC2</a:t>
+            </a:r>
+            <a:pPr algn="ctr" indent="0" marL="0">
+              <a:buNone/>
+            </a:pPr>
+            <a:r>
+              <a:rPr lang="en-US" sz="900" dirty="0">
+                <a:solidFill>
+                  <a:srgbClr val="9AA3B5"/>
+                </a:solidFill>
+                <a:latin typeface="Calibri" pitchFamily="34" charset="0"/>
+                <a:ea typeface="Calibri" pitchFamily="34" charset="-122"/>
+                <a:cs typeface="Calibri" pitchFamily="34" charset="-120"/>
+              </a:rPr>
+              <a:t>    |    </a:t>
+            </a:r>
+            <a:pPr algn="ctr" indent="0" marL="0">
+              <a:buNone/>
+            </a:pPr>
+            <a:r>
+              <a:rPr lang="en-US" sz="900" u="sng" dirty="0">
+                <a:solidFill>
+                  <a:srgbClr val="9AA3B5"/>
+                </a:solidFill>
+                <a:latin typeface="Calibri" pitchFamily="34" charset="0"/>
+                <a:ea typeface="Calibri" pitchFamily="34" charset="-122"/>
+                <a:cs typeface="Calibri" pitchFamily="34" charset="-120"/>
+                <a:hlinkClick r:id="rId2" invalidUrl="" action="" tgtFrame="" tooltip="" history="1" highlightClick="0" endSnd="0">
+                  <a:extLst>
+                    <a:ext uri="{A12FA001-AC4F-418D-AE19-62706E023703}">
+                      <ahyp:hlinkClr xmlns:ahyp="http://schemas.microsoft.com/office/drawing/2018/hyperlinkcolor" val="tx"/>
+                    </a:ext>
+                  </a:extLst>
+                </a:hlinkClick>
+              </a:rPr>
+              <a:t>linkedin.com/in/tiagofaustino91</a:t>
             </a:r>
             <a:endParaRPr lang="en-US" sz="900" dirty="0"/>
           </a:p>
@@ -6235,7 +6585,77 @@
                 <a:ea typeface="Calibri" pitchFamily="34" charset="-122"/>
                 <a:cs typeface="Calibri" pitchFamily="34" charset="-120"/>
               </a:rPr>
-              <a:t>FIAP – MLE10 – Machine Learning Engineering    |    github.com/tiagotff/FIAP_MLE10_TC2    |    linkedin.com/in/tiagofaustino91</a:t>
+              <a:t>FIAP – MLE10 – Machine Learning Engineering</a:t>
+            </a:r>
+            <a:pPr algn="ctr" indent="0" marL="0">
+              <a:buNone/>
+            </a:pPr>
+            <a:r>
+              <a:rPr lang="en-US" sz="900" dirty="0">
+                <a:solidFill>
+                  <a:srgbClr val="9DB2A6"/>
+                </a:solidFill>
+                <a:latin typeface="Calibri" pitchFamily="34" charset="0"/>
+                <a:ea typeface="Calibri" pitchFamily="34" charset="-122"/>
+                <a:cs typeface="Calibri" pitchFamily="34" charset="-120"/>
+              </a:rPr>
+              <a:t>    |    </a:t>
+            </a:r>
+            <a:pPr algn="ctr" indent="0" marL="0">
+              <a:buNone/>
+            </a:pPr>
+            <a:r>
+              <a:rPr lang="en-US" sz="900" u="sng" dirty="0">
+                <a:solidFill>
+                  <a:srgbClr val="9DB2A6"/>
+                </a:solidFill>
+                <a:latin typeface="Calibri" pitchFamily="34" charset="0"/>
+                <a:ea typeface="Calibri" pitchFamily="34" charset="-122"/>
+                <a:cs typeface="Calibri" pitchFamily="34" charset="-120"/>
+                <a:hlinkClick r:id="rId5" invalidUrl="" action="" tgtFrame="" tooltip="" history="1" highlightClick="0" endSnd="0">
+                  <a:extLst>
+                    <a:ext uri="{A12FA001-AC4F-418D-AE19-62706E023703}">
+                      <ahyp:hlinkClr xmlns:ahyp="http://schemas.microsoft.com/office/drawing/2018/hyperlinkcolor" val="tx"/>
+                    </a:ext>
+                  </a:extLst>
+                </a:hlinkClick>
+              </a:rPr>
+              <a:t>github.com/tiagotff/FIAP_MLE10_TC2</a:t>
+            </a:r>
+            <a:pPr algn="ctr" indent="0" marL="0">
+              <a:buNone/>
+            </a:pPr>
+            <a:r>
+              <a:rPr lang="en-US" sz="900" dirty="0">
+                <a:solidFill>
+                  <a:srgbClr val="9DB2A6"/>
+                </a:solidFill>
+                <a:latin typeface="Calibri" pitchFamily="34" charset="0"/>
+                <a:ea typeface="Calibri" pitchFamily="34" charset="-122"/>
+                <a:cs typeface="Calibri" pitchFamily="34" charset="-120"/>
+              </a:rPr>
+              <a:t>    |    </a:t>
+            </a:r>
+            <a:pPr algn="ctr" indent="0" marL="0">
+              <a:buNone/>
+            </a:pPr>
+            <a:r>
+              <a:rPr lang="en-US" sz="900" u="sng" dirty="0">
+                <a:solidFill>
+                  <a:srgbClr val="9DB2A6"/>
+                </a:solidFill>
+                <a:latin typeface="Calibri" pitchFamily="34" charset="0"/>
+                <a:ea typeface="Calibri" pitchFamily="34" charset="-122"/>
+                <a:cs typeface="Calibri" pitchFamily="34" charset="-120"/>
+                <a:hlinkClick r:id="rId6" invalidUrl="" action="" tgtFrame="" tooltip="" history="1" highlightClick="0" endSnd="0">
+                  <a:extLst>
+                    <a:ext uri="{A12FA001-AC4F-418D-AE19-62706E023703}">
+                      <ahyp:hlinkClr xmlns:ahyp="http://schemas.microsoft.com/office/drawing/2018/hyperlinkcolor" val="tx"/>
+                    </a:ext>
+                  </a:extLst>
+                </a:hlinkClick>
+              </a:rPr>
+              <a:t>linkedin.com/in/tiagofaustino91</a:t>
             </a:r>
             <a:endParaRPr lang="en-US" sz="900" dirty="0"/>
           </a:p>
@@ -9878,7 +10298,77 @@
                 <a:ea typeface="Calibri" pitchFamily="34" charset="-122"/>
                 <a:cs typeface="Calibri" pitchFamily="34" charset="-120"/>
               </a:rPr>
-              <a:t>FIAP – MLE10 – Machine Learning Engineering    |    github.com/tiagotff/FIAP_MLE10_TC2    |    linkedin.com/in/tiagofaustino91</a:t>
+              <a:t>FIAP – MLE10 – Machine Learning Engineering</a:t>
+            </a:r>
+            <a:pPr algn="ctr" indent="0" marL="0">
+              <a:buNone/>
+            </a:pPr>
+            <a:r>
+              <a:rPr lang="en-US" sz="900" dirty="0">
+                <a:solidFill>
+                  <a:srgbClr val="9AA3B5"/>
+                </a:solidFill>
+                <a:latin typeface="Calibri" pitchFamily="34" charset="0"/>
+                <a:ea typeface="Calibri" pitchFamily="34" charset="-122"/>
+                <a:cs typeface="Calibri" pitchFamily="34" charset="-120"/>
+              </a:rPr>
+              <a:t>    |    </a:t>
+            </a:r>
+            <a:pPr algn="ctr" indent="0" marL="0">
+              <a:buNone/>
+            </a:pPr>
+            <a:r>
+              <a:rPr lang="en-US" sz="900" u="sng" dirty="0">
+                <a:solidFill>
+                  <a:srgbClr val="9AA3B5"/>
+                </a:solidFill>
+                <a:latin typeface="Calibri" pitchFamily="34" charset="0"/>
+                <a:ea typeface="Calibri" pitchFamily="34" charset="-122"/>
+                <a:cs typeface="Calibri" pitchFamily="34" charset="-120"/>
+                <a:hlinkClick r:id="rId21" invalidUrl="" action="" tgtFrame="" tooltip="" history="1" highlightClick="0" endSnd="0">
+                  <a:extLst>
+                    <a:ext uri="{A12FA001-AC4F-418D-AE19-62706E023703}">
+                      <ahyp:hlinkClr xmlns:ahyp="http://schemas.microsoft.com/office/drawing/2018/hyperlinkcolor" val="tx"/>
+                    </a:ext>
+                  </a:extLst>
+                </a:hlinkClick>
+              </a:rPr>
+              <a:t>github.com/tiagotff/FIAP_MLE10_TC2</a:t>
+            </a:r>
+            <a:pPr algn="ctr" indent="0" marL="0">
+              <a:buNone/>
+            </a:pPr>
+            <a:r>
+              <a:rPr lang="en-US" sz="900" dirty="0">
+                <a:solidFill>
+                  <a:srgbClr val="9AA3B5"/>
+                </a:solidFill>
+                <a:latin typeface="Calibri" pitchFamily="34" charset="0"/>
+                <a:ea typeface="Calibri" pitchFamily="34" charset="-122"/>
+                <a:cs typeface="Calibri" pitchFamily="34" charset="-120"/>
+              </a:rPr>
+              <a:t>    |    </a:t>
+            </a:r>
+            <a:pPr algn="ctr" indent="0" marL="0">
+              <a:buNone/>
+            </a:pPr>
+            <a:r>
+              <a:rPr lang="en-US" sz="900" u="sng" dirty="0">
+                <a:solidFill>
+                  <a:srgbClr val="9AA3B5"/>
+                </a:solidFill>
+                <a:latin typeface="Calibri" pitchFamily="34" charset="0"/>
+                <a:ea typeface="Calibri" pitchFamily="34" charset="-122"/>
+                <a:cs typeface="Calibri" pitchFamily="34" charset="-120"/>
+                <a:hlinkClick r:id="rId22" invalidUrl="" action="" tgtFrame="" tooltip="" history="1" highlightClick="0" endSnd="0">
+                  <a:extLst>
+                    <a:ext uri="{A12FA001-AC4F-418D-AE19-62706E023703}">
+                      <ahyp:hlinkClr xmlns:ahyp="http://schemas.microsoft.com/office/drawing/2018/hyperlinkcolor" val="tx"/>
+                    </a:ext>
+                  </a:extLst>
+                </a:hlinkClick>
+              </a:rPr>
+              <a:t>linkedin.com/in/tiagofaustino91</a:t>
             </a:r>
             <a:endParaRPr lang="en-US" sz="900" dirty="0"/>
           </a:p>
@@ -10496,7 +10986,77 @@
                 <a:ea typeface="Calibri" pitchFamily="34" charset="-122"/>
                 <a:cs typeface="Calibri" pitchFamily="34" charset="-120"/>
               </a:rPr>
-              <a:t>FIAP – MLE10 – Machine Learning Engineering    |    github.com/tiagotff/FIAP_MLE10_TC2    |    linkedin.com/in/tiagofaustino91</a:t>
+              <a:t>FIAP – MLE10 – Machine Learning Engineering</a:t>
+            </a:r>
+            <a:pPr algn="ctr" indent="0" marL="0">
+              <a:buNone/>
+            </a:pPr>
+            <a:r>
+              <a:rPr lang="en-US" sz="900" dirty="0">
+                <a:solidFill>
+                  <a:srgbClr val="9AA3B5"/>
+                </a:solidFill>
+                <a:latin typeface="Calibri" pitchFamily="34" charset="0"/>
+                <a:ea typeface="Calibri" pitchFamily="34" charset="-122"/>
+                <a:cs typeface="Calibri" pitchFamily="34" charset="-120"/>
+              </a:rPr>
+              <a:t>    |    </a:t>
+            </a:r>
+            <a:pPr algn="ctr" indent="0" marL="0">
+              <a:buNone/>
+            </a:pPr>
+            <a:r>
+              <a:rPr lang="en-US" sz="900" u="sng" dirty="0">
+                <a:solidFill>
+                  <a:srgbClr val="9AA3B5"/>
+                </a:solidFill>
+                <a:latin typeface="Calibri" pitchFamily="34" charset="0"/>
+                <a:ea typeface="Calibri" pitchFamily="34" charset="-122"/>
+                <a:cs typeface="Calibri" pitchFamily="34" charset="-120"/>
+                <a:hlinkClick r:id="rId1" invalidUrl="" action="" tgtFrame="" tooltip="" history="1" highlightClick="0" endSnd="0">
+                  <a:extLst>
+                    <a:ext uri="{A12FA001-AC4F-418D-AE19-62706E023703}">
+                      <ahyp:hlinkClr xmlns:ahyp="http://schemas.microsoft.com/office/drawing/2018/hyperlinkcolor" val="tx"/>
+                    </a:ext>
+                  </a:extLst>
+                </a:hlinkClick>
+              </a:rPr>
+              <a:t>github.com/tiagotff/FIAP_MLE10_TC2</a:t>
+            </a:r>
+            <a:pPr algn="ctr" indent="0" marL="0">
+              <a:buNone/>
+            </a:pPr>
+            <a:r>
+              <a:rPr lang="en-US" sz="900" dirty="0">
+                <a:solidFill>
+                  <a:srgbClr val="9AA3B5"/>
+                </a:solidFill>
+                <a:latin typeface="Calibri" pitchFamily="34" charset="0"/>
+                <a:ea typeface="Calibri" pitchFamily="34" charset="-122"/>
+                <a:cs typeface="Calibri" pitchFamily="34" charset="-120"/>
+              </a:rPr>
+              <a:t>    |    </a:t>
+            </a:r>
+            <a:pPr algn="ctr" indent="0" marL="0">
+              <a:buNone/>
+            </a:pPr>
+            <a:r>
+              <a:rPr lang="en-US" sz="900" u="sng" dirty="0">
+                <a:solidFill>
+                  <a:srgbClr val="9AA3B5"/>
+                </a:solidFill>
+                <a:latin typeface="Calibri" pitchFamily="34" charset="0"/>
+                <a:ea typeface="Calibri" pitchFamily="34" charset="-122"/>
+                <a:cs typeface="Calibri" pitchFamily="34" charset="-120"/>
+                <a:hlinkClick r:id="rId2" invalidUrl="" action="" tgtFrame="" tooltip="" history="1" highlightClick="0" endSnd="0">
+                  <a:extLst>
+                    <a:ext uri="{A12FA001-AC4F-418D-AE19-62706E023703}">
+                      <ahyp:hlinkClr xmlns:ahyp="http://schemas.microsoft.com/office/drawing/2018/hyperlinkcolor" val="tx"/>
+                    </a:ext>
+                  </a:extLst>
+                </a:hlinkClick>
+              </a:rPr>
+              <a:t>linkedin.com/in/tiagofaustino91</a:t>
             </a:r>
             <a:endParaRPr lang="en-US" sz="900" dirty="0"/>
           </a:p>
@@ -10743,7 +11303,9 @@
       </p:pic>
       <p:sp>
         <p:nvSpPr>
-          <p:cNvPr id="9" name="Text 5"/>
+          <p:cNvPr id="9" name="Text 5">
+            <a:hlinkClick r:id="rId3" tooltip=""/>
+          </p:cNvPr>
           <p:cNvSpPr/>
           <p:nvPr/>
         </p:nvSpPr>
@@ -10766,13 +11328,20 @@
               <a:buNone/>
             </a:pPr>
             <a:r>
-              <a:rPr lang="en-US" sz="1050" b="1" dirty="0">
+              <a:rPr lang="en-US" sz="1050" b="1" u="sng" dirty="0">
                 <a:solidFill>
                   <a:srgbClr val="FFFFFF"/>
                 </a:solidFill>
                 <a:latin typeface="Calibri" pitchFamily="34" charset="0"/>
                 <a:ea typeface="Calibri" pitchFamily="34" charset="-122"/>
                 <a:cs typeface="Calibri" pitchFamily="34" charset="-120"/>
+                <a:hlinkClick r:id="rId3" invalidUrl="" action="" tgtFrame="" tooltip="" history="1" highlightClick="0" endSnd="0">
+                  <a:extLst>
+                    <a:ext uri="{A12FA001-AC4F-418D-AE19-62706E023703}">
+                      <ahyp:hlinkClr xmlns:ahyp="http://schemas.microsoft.com/office/drawing/2018/hyperlinkcolor" val="tx"/>
+                    </a:ext>
+                  </a:extLst>
+                </a:hlinkClick>
               </a:rPr>
               <a:t>github.com/tiagotff/FIAP_MLE10_TC2</a:t>
             </a:r>
@@ -10809,7 +11378,7 @@
           <p:nvPr/>
         </p:nvPicPr>
         <p:blipFill>
-          <a:blip r:embed="rId3"/>
+          <a:blip r:embed="rId4"/>
           <a:stretch>
             <a:fillRect/>
           </a:stretch>
@@ -10826,7 +11395,9 @@
       </p:pic>
       <p:sp>
         <p:nvSpPr>
-          <p:cNvPr id="12" name="Text 7"/>
+          <p:cNvPr id="12" name="Text 7">
+            <a:hlinkClick r:id="rId5" tooltip=""/>
+          </p:cNvPr>
           <p:cNvSpPr/>
           <p:nvPr/>
         </p:nvSpPr>
@@ -10849,13 +11420,20 @@
               <a:buNone/>
             </a:pPr>
             <a:r>
-              <a:rPr lang="en-US" sz="1050" b="1" dirty="0">
+              <a:rPr lang="en-US" sz="1050" b="1" u="sng" dirty="0">
                 <a:solidFill>
                   <a:srgbClr val="FFFFFF"/>
                 </a:solidFill>
                 <a:latin typeface="Calibri" pitchFamily="34" charset="0"/>
                 <a:ea typeface="Calibri" pitchFamily="34" charset="-122"/>
                 <a:cs typeface="Calibri" pitchFamily="34" charset="-120"/>
+                <a:hlinkClick r:id="rId5" invalidUrl="" action="" tgtFrame="" tooltip="" history="1" highlightClick="0" endSnd="0">
+                  <a:extLst>
+                    <a:ext uri="{A12FA001-AC4F-418D-AE19-62706E023703}">
+                      <ahyp:hlinkClr xmlns:ahyp="http://schemas.microsoft.com/office/drawing/2018/hyperlinkcolor" val="tx"/>
+                    </a:ext>
+                  </a:extLst>
+                </a:hlinkClick>
               </a:rPr>
               <a:t>linkedin.com/in/tiagofaustino91</a:t>
             </a:r>
@@ -10963,7 +11541,9 @@
       </p:sp>
       <p:sp>
         <p:nvSpPr>
-          <p:cNvPr id="16" name="Text 11"/>
+          <p:cNvPr id="16" name="Text 11">
+            <a:hlinkClick r:id="rId6" tooltip=""/>
+          </p:cNvPr>
           <p:cNvSpPr/>
           <p:nvPr/>
         </p:nvSpPr>
@@ -10986,13 +11566,20 @@
               <a:buNone/>
             </a:pPr>
             <a:r>
-              <a:rPr lang="en-US" sz="1200" dirty="0">
+              <a:rPr lang="en-US" sz="1200" u="sng" dirty="0">
                 <a:solidFill>
                   <a:srgbClr val="C9982F"/>
                 </a:solidFill>
                 <a:latin typeface="Calibri" pitchFamily="34" charset="0"/>
                 <a:ea typeface="Calibri" pitchFamily="34" charset="-122"/>
                 <a:cs typeface="Calibri" pitchFamily="34" charset="-120"/>
+                <a:hlinkClick r:id="rId6" invalidUrl="" action="" tgtFrame="" tooltip="" history="1" highlightClick="0" endSnd="0">
+                  <a:extLst>
+                    <a:ext uri="{A12FA001-AC4F-418D-AE19-62706E023703}">
+                      <ahyp:hlinkClr xmlns:ahyp="http://schemas.microsoft.com/office/drawing/2018/hyperlinkcolor" val="tx"/>
+                    </a:ext>
+                  </a:extLst>
+                </a:hlinkClick>
               </a:rPr>
               <a:t>recommender-api-761613283146.us-central1.run.app</a:t>
             </a:r>
@@ -11064,7 +11651,9 @@
       </p:sp>
       <p:sp>
         <p:nvSpPr>
-          <p:cNvPr id="19" name="Text 14"/>
+          <p:cNvPr id="19" name="Text 14">
+            <a:hlinkClick r:id="rId7" tooltip=""/>
+          </p:cNvPr>
           <p:cNvSpPr/>
           <p:nvPr/>
         </p:nvSpPr>
@@ -11087,13 +11676,20 @@
               <a:buNone/>
             </a:pPr>
             <a:r>
-              <a:rPr lang="en-US" sz="1200" dirty="0">
+              <a:rPr lang="en-US" sz="1200" u="sng" dirty="0">
                 <a:solidFill>
                   <a:srgbClr val="C9982F"/>
                 </a:solidFill>
                 <a:latin typeface="Calibri" pitchFamily="34" charset="0"/>
                 <a:ea typeface="Calibri" pitchFamily="34" charset="-122"/>
                 <a:cs typeface="Calibri" pitchFamily="34" charset="-120"/>
+                <a:hlinkClick r:id="rId7" invalidUrl="" action="" tgtFrame="" tooltip="" history="1" highlightClick="0" endSnd="0">
+                  <a:extLst>
+                    <a:ext uri="{A12FA001-AC4F-418D-AE19-62706E023703}">
+                      <ahyp:hlinkClr xmlns:ahyp="http://schemas.microsoft.com/office/drawing/2018/hyperlinkcolor" val="tx"/>
+                    </a:ext>
+                  </a:extLst>
+                </a:hlinkClick>
               </a:rPr>
               <a:t>recommender-dashboard-761613283146.us-central1.run.app</a:t>
             </a:r>
@@ -11165,7 +11761,9 @@
       </p:sp>
       <p:sp>
         <p:nvSpPr>
-          <p:cNvPr id="22" name="Text 17"/>
+          <p:cNvPr id="22" name="Text 17">
+            <a:hlinkClick r:id="rId8" tooltip=""/>
+          </p:cNvPr>
           <p:cNvSpPr/>
           <p:nvPr/>
         </p:nvSpPr>
@@ -11188,13 +11786,20 @@
               <a:buNone/>
             </a:pPr>
             <a:r>
-              <a:rPr lang="en-US" sz="1200" dirty="0">
+              <a:rPr lang="en-US" sz="1200" u="sng" dirty="0">
                 <a:solidFill>
                   <a:srgbClr val="C9982F"/>
                 </a:solidFill>
                 <a:latin typeface="Calibri" pitchFamily="34" charset="0"/>
                 <a:ea typeface="Calibri" pitchFamily="34" charset="-122"/>
                 <a:cs typeface="Calibri" pitchFamily="34" charset="-120"/>
+                <a:hlinkClick r:id="rId8" invalidUrl="" action="" tgtFrame="" tooltip="" history="1" highlightClick="0" endSnd="0">
+                  <a:extLst>
+                    <a:ext uri="{A12FA001-AC4F-418D-AE19-62706E023703}">
+                      <ahyp:hlinkClr xmlns:ahyp="http://schemas.microsoft.com/office/drawing/2018/hyperlinkcolor" val="tx"/>
+                    </a:ext>
+                  </a:extLst>
+                </a:hlinkClick>
               </a:rPr>
               <a:t>recommender-api-761613283146.us-central1.run.app/docs</a:t>
             </a:r>

</xml_diff>